<commit_message>
Atualização relatório e poster CoachAI
</commit_message>
<xml_diff>
--- a/CoachAI_Poster.pptx
+++ b/CoachAI_Poster.pptx
@@ -953,7 +953,7 @@
                 <a:ea typeface="Calibri" pitchFamily="34" charset="-122"/>
                 <a:cs typeface="Calibri" pitchFamily="34" charset="-120"/>
               </a:rPr>
-              <a:t>Afonso Silva</a:t>
+              <a:t>Afonso Silva al82140</a:t>
             </a:r>
             <a:endParaRPr lang="en-US" sz="4000" dirty="0"/>
           </a:p>
@@ -1320,109 +1320,66 @@
           <a:bodyPr wrap="square" lIns="0" tIns="0" rIns="0" bIns="0" rtlCol="0" anchor="ctr"/>
           <a:lstStyle/>
           <a:p>
-            <a:pPr marL="342900" indent="-342900">
-              <a:spcAft>
-                <a:spcPts val="600"/>
-              </a:spcAft>
-              <a:buSzPct val="100000"/>
-              <a:buChar char="•"/>
-            </a:pPr>
-            <a:r>
-              <a:rPr lang="en-US" sz="4400" dirty="0">
-                <a:solidFill>
-                  <a:srgbClr val="3D4A6B"/>
-                </a:solidFill>
-                <a:latin typeface="Calibri" pitchFamily="34" charset="0"/>
-                <a:ea typeface="Calibri" pitchFamily="34" charset="-122"/>
-                <a:cs typeface="Calibri" pitchFamily="34" charset="-120"/>
-              </a:rPr>
-              <a:t>Crescimento da utilização de IA no desporto e fitness</a:t>
-            </a:r>
-            <a:endParaRPr lang="en-US" sz="4400" dirty="0"/>
-          </a:p>
-          <a:p>
-            <a:pPr marL="342900" indent="-342900">
-              <a:spcAft>
-                <a:spcPts val="600"/>
-              </a:spcAft>
-              <a:buSzPct val="100000"/>
-              <a:buChar char="•"/>
-            </a:pPr>
-            <a:r>
-              <a:rPr lang="en-US" sz="4400" dirty="0">
-                <a:solidFill>
-                  <a:srgbClr val="3D4A6B"/>
-                </a:solidFill>
-                <a:latin typeface="Calibri" pitchFamily="34" charset="0"/>
-                <a:ea typeface="Calibri" pitchFamily="34" charset="-122"/>
-                <a:cs typeface="Calibri" pitchFamily="34" charset="-120"/>
-              </a:rPr>
-              <a:t>Human Pose Estimation permite analisar postura corporal em tempo real</a:t>
-            </a:r>
-            <a:endParaRPr lang="en-US" sz="4400" dirty="0"/>
-          </a:p>
-          <a:p>
-            <a:pPr marL="342900" indent="-342900">
-              <a:spcAft>
-                <a:spcPts val="600"/>
-              </a:spcAft>
-              <a:buSzPct val="100000"/>
-              <a:buChar char="•"/>
-            </a:pPr>
-            <a:r>
-              <a:rPr lang="en-US" sz="4400" dirty="0">
-                <a:solidFill>
-                  <a:srgbClr val="3D4A6B"/>
-                </a:solidFill>
-                <a:latin typeface="Calibri" pitchFamily="34" charset="0"/>
-                <a:ea typeface="Calibri" pitchFamily="34" charset="-122"/>
-                <a:cs typeface="Calibri" pitchFamily="34" charset="-120"/>
-              </a:rPr>
-              <a:t>Objetivo: avaliar a técnica de exercícios apenas com a câmara do smartphone</a:t>
-            </a:r>
-            <a:endParaRPr lang="en-US" sz="4400" dirty="0"/>
-          </a:p>
-          <a:p>
-            <a:pPr marL="342900" indent="-342900">
-              <a:spcAft>
-                <a:spcPts val="600"/>
-              </a:spcAft>
-              <a:buSzPct val="100000"/>
-              <a:buChar char="•"/>
-            </a:pPr>
-            <a:r>
-              <a:rPr lang="en-US" sz="4400" dirty="0">
-                <a:solidFill>
-                  <a:srgbClr val="3D4A6B"/>
-                </a:solidFill>
-                <a:latin typeface="Calibri" pitchFamily="34" charset="0"/>
-                <a:ea typeface="Calibri" pitchFamily="34" charset="-122"/>
-                <a:cs typeface="Calibri" pitchFamily="34" charset="-120"/>
-              </a:rPr>
-              <a:t>Processamento totalmente local (on-device), sem envio de dados para a cloud</a:t>
-            </a:r>
-            <a:endParaRPr lang="en-US" sz="4400" dirty="0"/>
-          </a:p>
-          <a:p>
-            <a:pPr marL="342900" indent="-342900">
-              <a:spcAft>
-                <a:spcPts val="600"/>
-              </a:spcAft>
-              <a:buSzPct val="100000"/>
-              <a:buChar char="•"/>
-            </a:pPr>
-            <a:r>
-              <a:rPr lang="en-US" sz="4400" dirty="0">
-                <a:solidFill>
-                  <a:srgbClr val="3D4A6B"/>
-                </a:solidFill>
-                <a:latin typeface="Calibri" pitchFamily="34" charset="0"/>
-                <a:ea typeface="Calibri" pitchFamily="34" charset="-122"/>
-                <a:cs typeface="Calibri" pitchFamily="34" charset="-120"/>
-              </a:rPr>
-              <a:t>Aplicação desenvolvida em Android com feedback visual imediato</a:t>
-            </a:r>
-            <a:endParaRPr lang="en-US" sz="4400" dirty="0"/>
+            <a:r>
+              <a:rPr lang="pt-PT" sz="4400" dirty="0"/>
+              <a:t>• A </a:t>
+            </a:r>
+            <a:r>
+              <a:rPr lang="pt-PT" sz="4400" b="1" dirty="0" err="1"/>
+              <a:t>Human</a:t>
+            </a:r>
+            <a:r>
+              <a:rPr lang="pt-PT" sz="4400" b="1" dirty="0"/>
+              <a:t> Pose </a:t>
+            </a:r>
+            <a:r>
+              <a:rPr lang="pt-PT" sz="4400" b="1" dirty="0" err="1"/>
+              <a:t>Estimation</a:t>
+            </a:r>
+            <a:r>
+              <a:rPr lang="pt-PT" sz="4400" b="1" dirty="0"/>
+              <a:t> (HPE) </a:t>
+            </a:r>
+            <a:r>
+              <a:rPr lang="pt-PT" sz="4400" dirty="0"/>
+              <a:t>tem vindo a ganhar relevância em aplicações de fitness, reabilitação e análise biomecânica.</a:t>
+            </a:r>
+          </a:p>
+          <a:p>
+            <a:r>
+              <a:rPr lang="pt-PT" sz="4400" dirty="0"/>
+              <a:t>• O </a:t>
+            </a:r>
+            <a:r>
+              <a:rPr lang="pt-PT" sz="4400" b="1" dirty="0" err="1"/>
+              <a:t>CoachAI</a:t>
+            </a:r>
+            <a:r>
+              <a:rPr lang="pt-PT" sz="4400" dirty="0"/>
+              <a:t> utiliza visão por computador para detetar </a:t>
+            </a:r>
+            <a:r>
+              <a:rPr lang="pt-PT" sz="4400" dirty="0" err="1"/>
+              <a:t>landmarks</a:t>
+            </a:r>
+            <a:r>
+              <a:rPr lang="pt-PT" sz="4400" dirty="0"/>
+              <a:t> corporais e analisar exercícios físicos em tempo real.</a:t>
+            </a:r>
+          </a:p>
+          <a:p>
+            <a:r>
+              <a:rPr lang="pt-PT" sz="4400" dirty="0"/>
+              <a:t>• O processamento é realizado totalmente </a:t>
+            </a:r>
+            <a:r>
+              <a:rPr lang="pt-PT" sz="4400" b="1" dirty="0" err="1"/>
+              <a:t>on-device</a:t>
+            </a:r>
+            <a:r>
+              <a:rPr lang="pt-PT" sz="4400" dirty="0"/>
+              <a:t>, garantindo baixa latência e maior privacidade dos dados.</a:t>
+            </a:r>
           </a:p>
         </p:txBody>
       </p:sp>
@@ -1572,7 +1529,7 @@
         <p:spPr>
           <a:xfrm>
             <a:off x="15768828" y="6400800"/>
-            <a:ext cx="13885164" cy="7248906"/>
+            <a:ext cx="6252972" cy="7248906"/>
           </a:xfrm>
           <a:prstGeom prst="rect">
             <a:avLst/>
@@ -1584,109 +1541,67 @@
           <a:bodyPr wrap="square" lIns="0" tIns="0" rIns="0" bIns="0" rtlCol="0" anchor="ctr"/>
           <a:lstStyle/>
           <a:p>
-            <a:pPr marL="342900" indent="-342900">
-              <a:spcAft>
-                <a:spcPts val="600"/>
-              </a:spcAft>
-              <a:buSzPct val="100000"/>
+            <a:pPr marL="571500" indent="-571500">
+              <a:buFont typeface="Arial" panose="020B0604020202020204" pitchFamily="34" charset="0"/>
               <a:buChar char="•"/>
             </a:pPr>
             <a:r>
-              <a:rPr lang="en-US" sz="4400" dirty="0">
-                <a:solidFill>
-                  <a:srgbClr val="3D4A6B"/>
-                </a:solidFill>
-                <a:latin typeface="Calibri" pitchFamily="34" charset="0"/>
-                <a:ea typeface="Calibri" pitchFamily="34" charset="-122"/>
-                <a:cs typeface="Calibri" pitchFamily="34" charset="-120"/>
-              </a:rPr>
-              <a:t>Detetar pose humana em tempo real via câmara do smartphone</a:t>
-            </a:r>
-            <a:endParaRPr lang="en-US" sz="4400" dirty="0"/>
-          </a:p>
-          <a:p>
-            <a:pPr marL="342900" indent="-342900">
-              <a:spcAft>
-                <a:spcPts val="600"/>
-              </a:spcAft>
-              <a:buSzPct val="100000"/>
+              <a:rPr lang="pt-PT" sz="4400" b="1" dirty="0"/>
+              <a:t>HPE</a:t>
+            </a:r>
+            <a:r>
+              <a:rPr lang="pt-PT" sz="4400" dirty="0"/>
+              <a:t> em tempo real</a:t>
+            </a:r>
+          </a:p>
+          <a:p>
+            <a:pPr marL="571500" indent="-571500">
+              <a:buFont typeface="Arial" panose="020B0604020202020204" pitchFamily="34" charset="0"/>
               <a:buChar char="•"/>
             </a:pPr>
             <a:r>
-              <a:rPr lang="en-US" sz="4400" dirty="0">
-                <a:solidFill>
-                  <a:srgbClr val="3D4A6B"/>
-                </a:solidFill>
-                <a:latin typeface="Calibri" pitchFamily="34" charset="0"/>
-                <a:ea typeface="Calibri" pitchFamily="34" charset="-122"/>
-                <a:cs typeface="Calibri" pitchFamily="34" charset="-120"/>
-              </a:rPr>
-              <a:t>Fornecer feedback corretivo visual e imediato</a:t>
-            </a:r>
-            <a:endParaRPr lang="en-US" sz="4400" dirty="0"/>
-          </a:p>
-          <a:p>
-            <a:pPr marL="342900" indent="-342900">
-              <a:spcAft>
-                <a:spcPts val="600"/>
-              </a:spcAft>
-              <a:buSzPct val="100000"/>
+              <a:rPr lang="pt-PT" sz="4400" dirty="0"/>
+              <a:t>Feedback corretivo automático</a:t>
+            </a:r>
+          </a:p>
+          <a:p>
+            <a:pPr marL="571500" indent="-571500">
+              <a:buFont typeface="Arial" panose="020B0604020202020204" pitchFamily="34" charset="0"/>
               <a:buChar char="•"/>
             </a:pPr>
             <a:r>
-              <a:rPr lang="en-US" sz="4400" dirty="0">
-                <a:solidFill>
-                  <a:srgbClr val="3D4A6B"/>
-                </a:solidFill>
-                <a:latin typeface="Calibri" pitchFamily="34" charset="0"/>
-                <a:ea typeface="Calibri" pitchFamily="34" charset="-122"/>
-                <a:cs typeface="Calibri" pitchFamily="34" charset="-120"/>
-              </a:rPr>
-              <a:t>Calcular métricas biomecânicas (ângulos articulares)</a:t>
-            </a:r>
-            <a:endParaRPr lang="en-US" sz="4400" dirty="0"/>
-          </a:p>
-          <a:p>
-            <a:pPr marL="342900" indent="-342900">
-              <a:spcAft>
-                <a:spcPts val="600"/>
-              </a:spcAft>
-              <a:buSzPct val="100000"/>
+              <a:rPr lang="pt-PT" sz="4400" dirty="0"/>
+              <a:t>Cálculo de ângulos articulares</a:t>
+            </a:r>
+          </a:p>
+          <a:p>
+            <a:pPr marL="571500" indent="-571500">
+              <a:buFont typeface="Arial" panose="020B0604020202020204" pitchFamily="34" charset="0"/>
               <a:buChar char="•"/>
             </a:pPr>
             <a:r>
-              <a:rPr lang="en-US" sz="4400" dirty="0">
-                <a:solidFill>
-                  <a:srgbClr val="3D4A6B"/>
-                </a:solidFill>
-                <a:latin typeface="Calibri" pitchFamily="34" charset="0"/>
-                <a:ea typeface="Calibri" pitchFamily="34" charset="-122"/>
-                <a:cs typeface="Calibri" pitchFamily="34" charset="-120"/>
-              </a:rPr>
-              <a:t>Comparar modelos de Human Pose Estimation</a:t>
-            </a:r>
-            <a:endParaRPr lang="en-US" sz="4400" dirty="0"/>
-          </a:p>
-          <a:p>
-            <a:pPr marL="342900" indent="-342900">
-              <a:spcAft>
-                <a:spcPts val="600"/>
-              </a:spcAft>
-              <a:buSzPct val="100000"/>
+              <a:rPr lang="pt-PT" sz="4400" dirty="0"/>
+              <a:t>Comparação de modelos </a:t>
+            </a:r>
+            <a:r>
+              <a:rPr lang="pt-PT" sz="4400" b="1" dirty="0"/>
+              <a:t>HPE</a:t>
+            </a:r>
+          </a:p>
+          <a:p>
+            <a:pPr marL="571500" indent="-571500">
+              <a:buFont typeface="Arial" panose="020B0604020202020204" pitchFamily="34" charset="0"/>
               <a:buChar char="•"/>
             </a:pPr>
             <a:r>
-              <a:rPr lang="en-US" sz="4400" dirty="0">
-                <a:solidFill>
-                  <a:srgbClr val="3D4A6B"/>
-                </a:solidFill>
-                <a:latin typeface="Calibri" pitchFamily="34" charset="0"/>
-                <a:ea typeface="Calibri" pitchFamily="34" charset="-122"/>
-                <a:cs typeface="Calibri" pitchFamily="34" charset="-120"/>
-              </a:rPr>
-              <a:t>Garantir processamento totalmente on-device</a:t>
-            </a:r>
-            <a:endParaRPr lang="en-US" sz="4400" dirty="0"/>
+              <a:rPr lang="pt-PT" sz="4400" dirty="0"/>
+              <a:t>Processamento totalmente </a:t>
+            </a:r>
+            <a:r>
+              <a:rPr lang="pt-PT" sz="4400" b="1" dirty="0" err="1"/>
+              <a:t>on-device</a:t>
+            </a:r>
+            <a:endParaRPr lang="pt-PT" sz="4400" b="1" dirty="0"/>
           </a:p>
         </p:txBody>
       </p:sp>
@@ -2432,8 +2347,8 @@
         </p:nvSpPr>
         <p:spPr>
           <a:xfrm>
-            <a:off x="15887700" y="25980292"/>
-            <a:ext cx="6896862" cy="3456335"/>
+            <a:off x="15914219" y="25576959"/>
+            <a:ext cx="6896862" cy="3442541"/>
           </a:xfrm>
           <a:prstGeom prst="roundRect">
             <a:avLst>
@@ -2466,12 +2381,8 @@
               <a:buChar char="•"/>
             </a:pPr>
             <a:r>
-              <a:rPr lang="pt-PT" sz="3600" dirty="0" err="1"/>
-              <a:t>MediaPipe</a:t>
-            </a:r>
-            <a:r>
               <a:rPr lang="pt-PT" sz="3600" dirty="0"/>
-              <a:t>: ~70 FPS </a:t>
+              <a:t>70–75 FPS em tempo real</a:t>
             </a:r>
           </a:p>
           <a:p>
@@ -2481,8 +2392,13 @@
             </a:pPr>
             <a:r>
               <a:rPr lang="pt-PT" sz="3600" dirty="0"/>
-              <a:t>YOLO Pose: ~35 FPS </a:t>
-            </a:r>
+              <a:t>Processamento totalmente </a:t>
+            </a:r>
+            <a:r>
+              <a:rPr lang="pt-PT" sz="3600" dirty="0" err="1"/>
+              <a:t>on-device</a:t>
+            </a:r>
+            <a:endParaRPr lang="pt-PT" sz="3600" dirty="0"/>
           </a:p>
           <a:p>
             <a:pPr marL="571500" indent="-571500">
@@ -2491,7 +2407,7 @@
             </a:pPr>
             <a:r>
               <a:rPr lang="pt-PT" sz="3600" dirty="0"/>
-              <a:t>Processamento local em tempo real </a:t>
+              <a:t>Feedback imediato ao utilizador</a:t>
             </a:r>
           </a:p>
           <a:p>
@@ -2504,6 +2420,16 @@
               <a:t>Baixa latência</a:t>
             </a:r>
           </a:p>
+          <a:p>
+            <a:pPr marL="571500" indent="-571500">
+              <a:buFont typeface="Arial" panose="020B0604020202020204" pitchFamily="34" charset="0"/>
+              <a:buChar char="•"/>
+            </a:pPr>
+            <a:r>
+              <a:rPr lang="pt-PT" sz="3600" dirty="0"/>
+              <a:t>Experiência fluida</a:t>
+            </a:r>
+          </a:p>
         </p:txBody>
       </p:sp>
       <p:sp>
@@ -2514,7 +2440,7 @@
         </p:nvSpPr>
         <p:spPr>
           <a:xfrm>
-            <a:off x="15907155" y="25164745"/>
+            <a:off x="15933674" y="24830532"/>
             <a:ext cx="6896862" cy="685800"/>
           </a:xfrm>
           <a:prstGeom prst="rect">
@@ -2541,7 +2467,7 @@
         </p:nvSpPr>
         <p:spPr>
           <a:xfrm>
-            <a:off x="15887700" y="25164745"/>
+            <a:off x="15914219" y="24830532"/>
             <a:ext cx="6896862" cy="685800"/>
           </a:xfrm>
           <a:prstGeom prst="rect">
@@ -2554,32 +2480,23 @@
           <a:bodyPr wrap="square" lIns="0" tIns="0" rIns="0" bIns="0" rtlCol="0" anchor="ctr"/>
           <a:lstStyle/>
           <a:p>
-            <a:pPr marL="0" indent="0" algn="ctr">
-              <a:buNone/>
-            </a:pPr>
-            <a:r>
-              <a:rPr lang="en-US" sz="5400" b="1" dirty="0">
+            <a:pPr algn="ctr"/>
+            <a:r>
+              <a:rPr lang="en-US" sz="4800" b="1" dirty="0" err="1">
                 <a:solidFill>
-                  <a:srgbClr val="FFFFFF"/>
+                  <a:schemeClr val="bg1"/>
                 </a:solidFill>
-                <a:latin typeface="Calibri" pitchFamily="34" charset="0"/>
-                <a:ea typeface="Calibri" pitchFamily="34" charset="-122"/>
-                <a:cs typeface="Calibri" pitchFamily="34" charset="-120"/>
               </a:rPr>
-              <a:t>FPS </a:t>
-            </a:r>
-            <a:r>
-              <a:rPr lang="en-US" sz="5400" b="1" dirty="0" err="1">
+              <a:t>Resultado</a:t>
+            </a:r>
+            <a:r>
+              <a:rPr lang="en-US" sz="4800" b="1" dirty="0">
                 <a:solidFill>
-                  <a:srgbClr val="FFFFFF"/>
+                  <a:schemeClr val="bg1"/>
                 </a:solidFill>
-                <a:latin typeface="Calibri" pitchFamily="34" charset="0"/>
-                <a:ea typeface="Calibri" pitchFamily="34" charset="-122"/>
-                <a:cs typeface="Calibri" pitchFamily="34" charset="-120"/>
               </a:rPr>
-              <a:t>Elevados</a:t>
-            </a:r>
-            <a:endParaRPr lang="en-US" sz="5400" dirty="0"/>
+              <a:t> Principal</a:t>
+            </a:r>
           </a:p>
         </p:txBody>
       </p:sp>
@@ -2702,7 +2619,7 @@
           <a:p>
             <a:r>
               <a:rPr lang="pt-PT" sz="5400" b="1" dirty="0"/>
-              <a:t>Desafios Técnicos</a:t>
+              <a:t>Variação Angular</a:t>
             </a:r>
             <a:endParaRPr lang="en-US" sz="5400" b="1" dirty="0"/>
           </a:p>
@@ -2735,133 +2652,6 @@
           <a:lstStyle/>
           <a:p>
             <a:endParaRPr lang="pt-PT"/>
-          </a:p>
-        </p:txBody>
-      </p:sp>
-      <p:sp>
-        <p:nvSpPr>
-          <p:cNvPr id="102" name="Text 96"/>
-          <p:cNvSpPr/>
-          <p:nvPr/>
-        </p:nvSpPr>
-        <p:spPr>
-          <a:xfrm>
-            <a:off x="886968" y="32810958"/>
-            <a:ext cx="13885164" cy="7248906"/>
-          </a:xfrm>
-          <a:prstGeom prst="rect">
-            <a:avLst/>
-          </a:prstGeom>
-          <a:noFill/>
-          <a:ln/>
-        </p:spPr>
-        <p:txBody>
-          <a:bodyPr wrap="square" lIns="0" tIns="0" rIns="0" bIns="0" rtlCol="0" anchor="ctr"/>
-          <a:lstStyle/>
-          <a:p>
-            <a:pPr marL="342900" indent="-342900">
-              <a:spcAft>
-                <a:spcPts val="600"/>
-              </a:spcAft>
-              <a:buSzPct val="100000"/>
-              <a:buChar char="•"/>
-            </a:pPr>
-            <a:r>
-              <a:rPr lang="en-US" sz="4400" dirty="0">
-                <a:solidFill>
-                  <a:srgbClr val="3D4A6B"/>
-                </a:solidFill>
-                <a:latin typeface="Calibri" pitchFamily="34" charset="0"/>
-                <a:ea typeface="Calibri" pitchFamily="34" charset="-122"/>
-                <a:cs typeface="Calibri" pitchFamily="34" charset="-120"/>
-              </a:rPr>
-              <a:t>Erros de formato de imagem ARGB_8888 na câmara Android</a:t>
-            </a:r>
-            <a:endParaRPr lang="en-US" sz="4400" dirty="0"/>
-          </a:p>
-          <a:p>
-            <a:pPr marL="342900" indent="-342900">
-              <a:spcAft>
-                <a:spcPts val="600"/>
-              </a:spcAft>
-              <a:buSzPct val="100000"/>
-              <a:buChar char="•"/>
-            </a:pPr>
-            <a:r>
-              <a:rPr lang="en-US" sz="4400" dirty="0">
-                <a:solidFill>
-                  <a:srgbClr val="3D4A6B"/>
-                </a:solidFill>
-                <a:latin typeface="Calibri" pitchFamily="34" charset="0"/>
-                <a:ea typeface="Calibri" pitchFamily="34" charset="-122"/>
-                <a:cs typeface="Calibri" pitchFamily="34" charset="-120"/>
-              </a:rPr>
-              <a:t>Conflitos entre versões de bibliotecas do Android</a:t>
-            </a:r>
-            <a:endParaRPr lang="en-US" sz="4400" dirty="0"/>
-          </a:p>
-          <a:p>
-            <a:pPr marL="342900" indent="-342900">
-              <a:spcAft>
-                <a:spcPts val="600"/>
-              </a:spcAft>
-              <a:buSzPct val="100000"/>
-              <a:buChar char="•"/>
-            </a:pPr>
-            <a:r>
-              <a:rPr lang="en-US" sz="4400" dirty="0">
-                <a:solidFill>
-                  <a:srgbClr val="3D4A6B"/>
-                </a:solidFill>
-                <a:latin typeface="Calibri" pitchFamily="34" charset="0"/>
-                <a:ea typeface="Calibri" pitchFamily="34" charset="-122"/>
-                <a:cs typeface="Calibri" pitchFamily="34" charset="-120"/>
-              </a:rPr>
-              <a:t>Imports e configurações do MediaPipe Tasks</a:t>
-            </a:r>
-            <a:endParaRPr lang="en-US" sz="4400" dirty="0"/>
-          </a:p>
-          <a:p>
-            <a:pPr marL="342900" indent="-342900">
-              <a:spcAft>
-                <a:spcPts val="600"/>
-              </a:spcAft>
-              <a:buSzPct val="100000"/>
-              <a:buChar char="•"/>
-            </a:pPr>
-            <a:r>
-              <a:rPr lang="en-US" sz="4400" dirty="0">
-                <a:solidFill>
-                  <a:srgbClr val="3D4A6B"/>
-                </a:solidFill>
-                <a:latin typeface="Calibri" pitchFamily="34" charset="0"/>
-                <a:ea typeface="Calibri" pitchFamily="34" charset="-122"/>
-                <a:cs typeface="Calibri" pitchFamily="34" charset="-120"/>
-              </a:rPr>
-              <a:t>Otimização de FPS para processamento em tempo real</a:t>
-            </a:r>
-            <a:endParaRPr lang="en-US" sz="4400" dirty="0"/>
-          </a:p>
-          <a:p>
-            <a:pPr marL="342900" indent="-342900">
-              <a:spcAft>
-                <a:spcPts val="600"/>
-              </a:spcAft>
-              <a:buSzPct val="100000"/>
-              <a:buChar char="•"/>
-            </a:pPr>
-            <a:r>
-              <a:rPr lang="en-US" sz="4400" dirty="0">
-                <a:solidFill>
-                  <a:srgbClr val="3D4A6B"/>
-                </a:solidFill>
-                <a:latin typeface="Calibri" pitchFamily="34" charset="0"/>
-                <a:ea typeface="Calibri" pitchFamily="34" charset="-122"/>
-                <a:cs typeface="Calibri" pitchFamily="34" charset="-120"/>
-              </a:rPr>
-              <a:t>Deteção de utilizador de costas / ângulos não frontais</a:t>
-            </a:r>
-            <a:endParaRPr lang="en-US" sz="4400" dirty="0"/>
           </a:p>
         </p:txBody>
       </p:sp>
@@ -3004,40 +2794,6 @@
       </p:sp>
       <p:sp>
         <p:nvSpPr>
-          <p:cNvPr id="107" name="Shape 101"/>
-          <p:cNvSpPr/>
-          <p:nvPr/>
-        </p:nvSpPr>
-        <p:spPr>
-          <a:xfrm>
-            <a:off x="15768828" y="32810958"/>
-            <a:ext cx="13885164" cy="7248906"/>
-          </a:xfrm>
-          <a:prstGeom prst="roundRect">
-            <a:avLst>
-              <a:gd name="adj" fmla="val 1009"/>
-            </a:avLst>
-          </a:prstGeom>
-          <a:solidFill>
-            <a:srgbClr val="EFF3FB"/>
-          </a:solidFill>
-          <a:ln w="19050">
-            <a:solidFill>
-              <a:srgbClr val="2C3E6B"/>
-            </a:solidFill>
-            <a:prstDash val="solid"/>
-          </a:ln>
-        </p:spPr>
-        <p:txBody>
-          <a:bodyPr/>
-          <a:lstStyle/>
-          <a:p>
-            <a:endParaRPr lang="pt-PT"/>
-          </a:p>
-        </p:txBody>
-      </p:sp>
-      <p:sp>
-        <p:nvSpPr>
           <p:cNvPr id="108" name="Text 102"/>
           <p:cNvSpPr/>
           <p:nvPr/>
@@ -3045,7 +2801,7 @@
         <p:spPr>
           <a:xfrm>
             <a:off x="16024860" y="32993838"/>
-            <a:ext cx="13473684" cy="6883146"/>
+            <a:ext cx="6467094" cy="6883146"/>
           </a:xfrm>
           <a:prstGeom prst="rect">
             <a:avLst/>
@@ -3057,67 +2813,41 @@
           <a:bodyPr wrap="square" lIns="0" tIns="0" rIns="0" bIns="0" rtlCol="0" anchor="ctr"/>
           <a:lstStyle/>
           <a:p>
-            <a:pPr marL="0" indent="0">
-              <a:buNone/>
-            </a:pPr>
-            <a:r>
-              <a:rPr lang="en-US" sz="4400" dirty="0">
-                <a:solidFill>
-                  <a:srgbClr val="1A1A2E"/>
-                </a:solidFill>
-                <a:latin typeface="Calibri" pitchFamily="34" charset="0"/>
-                <a:ea typeface="Calibri" pitchFamily="34" charset="-122"/>
-                <a:cs typeface="Calibri" pitchFamily="34" charset="-120"/>
-              </a:rPr>
-              <a:t>O CoachAI demonstrou o potencial da Human Pose Estimation em dispositivos móveis para análise técnica de exercícios físicos em tempo real.</a:t>
-            </a:r>
-            <a:endParaRPr lang="en-US" sz="4400" dirty="0"/>
-          </a:p>
-          <a:p>
-            <a:pPr marL="0" indent="0">
-              <a:buNone/>
-            </a:pPr>
-            <a:endParaRPr lang="en-US" sz="4400" dirty="0"/>
-          </a:p>
-          <a:p>
-            <a:pPr marL="0" indent="0">
-              <a:buNone/>
-            </a:pPr>
-            <a:r>
-              <a:rPr lang="en-US" sz="4400" dirty="0">
-                <a:solidFill>
-                  <a:srgbClr val="1A1A2E"/>
-                </a:solidFill>
-                <a:latin typeface="Calibri" pitchFamily="34" charset="0"/>
-                <a:ea typeface="Calibri" pitchFamily="34" charset="-122"/>
-                <a:cs typeface="Calibri" pitchFamily="34" charset="-120"/>
-              </a:rPr>
-              <a:t>O sistema processa vídeo localmente, calcula métricas biomecânicas e fornece feedback visual imediato ao utilizador — sem depender de conectividade à internet.</a:t>
-            </a:r>
-            <a:endParaRPr lang="en-US" sz="4400" dirty="0"/>
-          </a:p>
-          <a:p>
-            <a:pPr marL="0" indent="0">
-              <a:buNone/>
-            </a:pPr>
-            <a:endParaRPr lang="en-US" sz="4400" dirty="0"/>
-          </a:p>
-          <a:p>
-            <a:pPr marL="0" indent="0">
-              <a:buNone/>
-            </a:pPr>
-            <a:r>
-              <a:rPr lang="en-US" sz="4400" dirty="0">
-                <a:solidFill>
-                  <a:srgbClr val="1A1A2E"/>
-                </a:solidFill>
-                <a:latin typeface="Calibri" pitchFamily="34" charset="0"/>
-                <a:ea typeface="Calibri" pitchFamily="34" charset="-122"/>
-                <a:cs typeface="Calibri" pitchFamily="34" charset="-120"/>
-              </a:rPr>
-              <a:t>Trabalho futuro inclui suporte a mais exercícios, melhoria da deteção lateral e comparação completa de modelos HPE.</a:t>
-            </a:r>
-            <a:endParaRPr lang="en-US" sz="2200" dirty="0"/>
+            <a:r>
+              <a:rPr lang="pt-PT" sz="4400" dirty="0"/>
+              <a:t>• </a:t>
+            </a:r>
+            <a:r>
+              <a:rPr lang="pt-PT" sz="4400" b="1" dirty="0"/>
+              <a:t>HPE</a:t>
+            </a:r>
+            <a:r>
+              <a:rPr lang="pt-PT" sz="4400" dirty="0"/>
+              <a:t> em tempo real num smartphone</a:t>
+            </a:r>
+          </a:p>
+          <a:p>
+            <a:r>
+              <a:rPr lang="pt-PT" sz="4400" dirty="0"/>
+              <a:t>• Processamento totalmente </a:t>
+            </a:r>
+            <a:r>
+              <a:rPr lang="pt-PT" sz="4400" b="1" dirty="0" err="1"/>
+              <a:t>on-device</a:t>
+            </a:r>
+            <a:endParaRPr lang="pt-PT" sz="4400" b="1" dirty="0"/>
+          </a:p>
+          <a:p>
+            <a:r>
+              <a:rPr lang="pt-PT" sz="4400" dirty="0"/>
+              <a:t>• Cálculo automático de ângulos articulares</a:t>
+            </a:r>
+          </a:p>
+          <a:p>
+            <a:r>
+              <a:rPr lang="pt-PT" sz="4400" dirty="0"/>
+              <a:t>• Feedback visual imediato</a:t>
+            </a:r>
           </a:p>
         </p:txBody>
       </p:sp>
@@ -3278,19 +3008,11 @@
               <a:buChar char="•"/>
             </a:pPr>
             <a:r>
-              <a:rPr lang="pt-PT" sz="4400" b="1" dirty="0" err="1">
-                <a:solidFill>
-                  <a:srgbClr val="3D4A6B"/>
-                </a:solidFill>
-              </a:rPr>
+              <a:rPr lang="pt-PT" sz="4400" b="1" dirty="0" err="1"/>
               <a:t>Kotlin</a:t>
             </a:r>
             <a:r>
-              <a:rPr lang="pt-PT" sz="4400" dirty="0">
-                <a:solidFill>
-                  <a:srgbClr val="3D4A6B"/>
-                </a:solidFill>
-              </a:rPr>
+              <a:rPr lang="pt-PT" sz="4400" dirty="0"/>
               <a:t> – Aplicação Android</a:t>
             </a:r>
           </a:p>
@@ -3300,19 +3022,11 @@
               <a:buChar char="•"/>
             </a:pPr>
             <a:r>
-              <a:rPr lang="pt-PT" sz="4400" b="1" dirty="0" err="1">
-                <a:solidFill>
-                  <a:srgbClr val="3D4A6B"/>
-                </a:solidFill>
-              </a:rPr>
+              <a:rPr lang="pt-PT" sz="4400" b="1" dirty="0" err="1"/>
               <a:t>CameraX</a:t>
             </a:r>
             <a:r>
-              <a:rPr lang="pt-PT" sz="4400" dirty="0">
-                <a:solidFill>
-                  <a:srgbClr val="3D4A6B"/>
-                </a:solidFill>
-              </a:rPr>
+              <a:rPr lang="pt-PT" sz="4400" dirty="0"/>
               <a:t> – Captura de vídeo</a:t>
             </a:r>
           </a:p>
@@ -3322,43 +3036,23 @@
               <a:buChar char="•"/>
             </a:pPr>
             <a:r>
-              <a:rPr lang="pt-PT" sz="4400" b="1" dirty="0" err="1">
-                <a:solidFill>
-                  <a:srgbClr val="3D4A6B"/>
-                </a:solidFill>
-              </a:rPr>
+              <a:rPr lang="pt-PT" sz="4400" b="1" dirty="0" err="1"/>
               <a:t>MediaPipe</a:t>
             </a:r>
             <a:r>
-              <a:rPr lang="pt-PT" sz="4400" b="1" dirty="0">
-                <a:solidFill>
-                  <a:srgbClr val="3D4A6B"/>
-                </a:solidFill>
-              </a:rPr>
+              <a:rPr lang="pt-PT" sz="4400" b="1" dirty="0"/>
               <a:t> Pose </a:t>
             </a:r>
             <a:r>
-              <a:rPr lang="pt-PT" sz="4400" b="1" dirty="0" err="1">
-                <a:solidFill>
-                  <a:srgbClr val="3D4A6B"/>
-                </a:solidFill>
-              </a:rPr>
+              <a:rPr lang="pt-PT" sz="4400" b="1" dirty="0" err="1"/>
               <a:t>Landmarker</a:t>
             </a:r>
             <a:r>
-              <a:rPr lang="pt-PT" sz="4400" b="1" dirty="0">
-                <a:solidFill>
-                  <a:srgbClr val="3D4A6B"/>
-                </a:solidFill>
-              </a:rPr>
+              <a:rPr lang="pt-PT" sz="4400" b="1" dirty="0"/>
               <a:t> </a:t>
             </a:r>
             <a:r>
-              <a:rPr lang="pt-PT" sz="4400" dirty="0">
-                <a:solidFill>
-                  <a:srgbClr val="3D4A6B"/>
-                </a:solidFill>
-              </a:rPr>
+              <a:rPr lang="pt-PT" sz="4400" dirty="0"/>
               <a:t>– Deteção da pose humana</a:t>
             </a:r>
           </a:p>
@@ -3368,19 +3062,11 @@
               <a:buChar char="•"/>
             </a:pPr>
             <a:r>
-              <a:rPr lang="pt-PT" sz="4400" b="1" dirty="0" err="1">
-                <a:solidFill>
-                  <a:srgbClr val="3D4A6B"/>
-                </a:solidFill>
-              </a:rPr>
+              <a:rPr lang="pt-PT" sz="4400" b="1" dirty="0" err="1"/>
               <a:t>OpenCV</a:t>
             </a:r>
             <a:r>
-              <a:rPr lang="pt-PT" sz="4400" dirty="0">
-                <a:solidFill>
-                  <a:srgbClr val="3D4A6B"/>
-                </a:solidFill>
-              </a:rPr>
+              <a:rPr lang="pt-PT" sz="4400" dirty="0"/>
               <a:t> – Processamento de imagem</a:t>
             </a:r>
           </a:p>
@@ -3390,19 +3076,11 @@
               <a:buChar char="•"/>
             </a:pPr>
             <a:r>
-              <a:rPr lang="pt-PT" sz="4400" b="1" dirty="0">
-                <a:solidFill>
-                  <a:srgbClr val="3D4A6B"/>
-                </a:solidFill>
-              </a:rPr>
+              <a:rPr lang="pt-PT" sz="4400" b="1" dirty="0"/>
               <a:t>Análise de FPS </a:t>
             </a:r>
             <a:r>
-              <a:rPr lang="pt-PT" sz="4400" dirty="0">
-                <a:solidFill>
-                  <a:srgbClr val="3D4A6B"/>
-                </a:solidFill>
-              </a:rPr>
+              <a:rPr lang="pt-PT" sz="4400" dirty="0"/>
               <a:t>– Avaliação de desempenho</a:t>
             </a:r>
           </a:p>
@@ -3441,6 +3119,136 @@
           </a:prstGeom>
         </p:spPr>
       </p:pic>
+      <p:pic>
+        <p:nvPicPr>
+          <p:cNvPr id="32" name="Imagem 31" descr="The diagram illustrates the angular variation of the elbow, with values ranging from 180 to 0 degrees over time.&#10;&#10;Os conteúdos gerados por IA podem estar incorretos.">
+            <a:extLst>
+              <a:ext uri="{FF2B5EF4-FFF2-40B4-BE49-F238E27FC236}">
+                <a16:creationId xmlns:a16="http://schemas.microsoft.com/office/drawing/2014/main" id="{C2BE8B69-F6C4-D5D2-C1A3-233AE0C2EFA8}"/>
+              </a:ext>
+            </a:extLst>
+          </p:cNvPr>
+          <p:cNvPicPr>
+            <a:picLocks noChangeAspect="1"/>
+          </p:cNvPicPr>
+          <p:nvPr/>
+        </p:nvPicPr>
+        <p:blipFill>
+          <a:blip r:embed="rId11"/>
+          <a:stretch>
+            <a:fillRect/>
+          </a:stretch>
+        </p:blipFill>
+        <p:spPr>
+          <a:xfrm>
+            <a:off x="770859" y="32794947"/>
+            <a:ext cx="14119574" cy="7214633"/>
+          </a:xfrm>
+          <a:prstGeom prst="rect">
+            <a:avLst/>
+          </a:prstGeom>
+        </p:spPr>
+      </p:pic>
+      <p:pic>
+        <p:nvPicPr>
+          <p:cNvPr id="37" name="Imagem 36" descr="A figure is captured mid-pose, wearing a black and blue outfit, with a black belt, and marked by grid lines on a wall.&#10;&#10;Os conteúdos gerados por IA podem estar incorretos.">
+            <a:extLst>
+              <a:ext uri="{FF2B5EF4-FFF2-40B4-BE49-F238E27FC236}">
+                <a16:creationId xmlns:a16="http://schemas.microsoft.com/office/drawing/2014/main" id="{0864E0A7-633D-620E-F2F3-7FC58AA6C702}"/>
+              </a:ext>
+            </a:extLst>
+          </p:cNvPr>
+          <p:cNvPicPr>
+            <a:picLocks noChangeAspect="1"/>
+          </p:cNvPicPr>
+          <p:nvPr/>
+        </p:nvPicPr>
+        <p:blipFill>
+          <a:blip r:embed="rId12"/>
+          <a:stretch>
+            <a:fillRect/>
+          </a:stretch>
+        </p:blipFill>
+        <p:spPr>
+          <a:xfrm>
+            <a:off x="23272242" y="6716909"/>
+            <a:ext cx="4391660" cy="6882627"/>
+          </a:xfrm>
+          <a:prstGeom prst="rect">
+            <a:avLst/>
+          </a:prstGeom>
+        </p:spPr>
+      </p:pic>
+      <p:pic>
+        <p:nvPicPr>
+          <p:cNvPr id="41" name="Imagem 40" descr="The image depicts a person in a blue tracksuit, performing a balancing exercise with a white plastic bar on a black mat.&#10;&#10;Os conteúdos gerados por IA podem estar incorretos.">
+            <a:extLst>
+              <a:ext uri="{FF2B5EF4-FFF2-40B4-BE49-F238E27FC236}">
+                <a16:creationId xmlns:a16="http://schemas.microsoft.com/office/drawing/2014/main" id="{2DAC6913-39BA-0175-89C1-67C5A49B1DC0}"/>
+              </a:ext>
+            </a:extLst>
+          </p:cNvPr>
+          <p:cNvPicPr>
+            <a:picLocks noChangeAspect="1"/>
+          </p:cNvPicPr>
+          <p:nvPr/>
+        </p:nvPicPr>
+        <p:blipFill>
+          <a:blip r:embed="rId13"/>
+          <a:stretch>
+            <a:fillRect/>
+          </a:stretch>
+        </p:blipFill>
+        <p:spPr>
+          <a:xfrm>
+            <a:off x="23863948" y="33116838"/>
+            <a:ext cx="3208247" cy="6883146"/>
+          </a:xfrm>
+          <a:prstGeom prst="rect">
+            <a:avLst/>
+          </a:prstGeom>
+        </p:spPr>
+      </p:pic>
+      <p:sp>
+        <p:nvSpPr>
+          <p:cNvPr id="30" name="CaixaDeTexto 29">
+            <a:extLst>
+              <a:ext uri="{FF2B5EF4-FFF2-40B4-BE49-F238E27FC236}">
+                <a16:creationId xmlns:a16="http://schemas.microsoft.com/office/drawing/2014/main" id="{0C2248F6-4DE2-9C95-5774-81BD8ECEBDA0}"/>
+              </a:ext>
+            </a:extLst>
+          </p:cNvPr>
+          <p:cNvSpPr txBox="1"/>
+          <p:nvPr/>
+        </p:nvSpPr>
+        <p:spPr>
+          <a:xfrm>
+            <a:off x="15859625" y="29051595"/>
+            <a:ext cx="6919722" cy="523220"/>
+          </a:xfrm>
+          <a:prstGeom prst="rect">
+            <a:avLst/>
+          </a:prstGeom>
+          <a:noFill/>
+        </p:spPr>
+        <p:txBody>
+          <a:bodyPr wrap="square" rtlCol="0">
+            <a:spAutoFit/>
+          </a:bodyPr>
+          <a:lstStyle/>
+          <a:p>
+            <a:pPr algn="ctr"/>
+            <a:r>
+              <a:rPr lang="pt-PT" sz="2800" b="1" dirty="0" err="1"/>
+              <a:t>MediaPipe</a:t>
+            </a:r>
+            <a:r>
+              <a:rPr lang="pt-PT" sz="2800" b="1" dirty="0"/>
+              <a:t> ≈ 2× mais rápido que YOLO Pose</a:t>
+            </a:r>
+          </a:p>
+        </p:txBody>
+      </p:sp>
     </p:spTree>
   </p:cSld>
   <p:clrMapOvr>

</xml_diff>

<commit_message>
Atualização poster CoachAI 2
</commit_message>
<xml_diff>
--- a/CoachAI_Poster.pptx
+++ b/CoachAI_Poster.pptx
@@ -1351,12 +1351,12 @@
               <a:t>• O </a:t>
             </a:r>
             <a:r>
-              <a:rPr lang="pt-PT" sz="4400" b="1" dirty="0" err="1"/>
+              <a:rPr lang="pt-PT" sz="4400" dirty="0" err="1"/>
               <a:t>CoachAI</a:t>
             </a:r>
             <a:r>
               <a:rPr lang="pt-PT" sz="4400" dirty="0"/>
-              <a:t> utiliza visão por computador para detetar </a:t>
+              <a:t> usa a câmara do smartphone e visão por computador para detetar </a:t>
             </a:r>
             <a:r>
               <a:rPr lang="pt-PT" sz="4400" dirty="0" err="1"/>
@@ -1595,7 +1595,7 @@
             </a:pPr>
             <a:r>
               <a:rPr lang="pt-PT" sz="4400" dirty="0"/>
-              <a:t>Processamento totalmente </a:t>
+              <a:t>Processamento real-time </a:t>
             </a:r>
             <a:r>
               <a:rPr lang="pt-PT" sz="4400" b="1" dirty="0" err="1"/>
@@ -2989,8 +2989,8 @@
         </p:nvSpPr>
         <p:spPr>
           <a:xfrm>
-            <a:off x="1110996" y="15729632"/>
-            <a:ext cx="8213344" cy="5786199"/>
+            <a:off x="1099873" y="16662781"/>
+            <a:ext cx="8213344" cy="4154984"/>
           </a:xfrm>
           <a:prstGeom prst="rect">
             <a:avLst/>
@@ -3069,23 +3069,6 @@
               <a:rPr lang="pt-PT" sz="4400" dirty="0"/>
               <a:t> – Processamento de imagem</a:t>
             </a:r>
-          </a:p>
-          <a:p>
-            <a:pPr marL="571500" indent="-571500">
-              <a:buFont typeface="Arial" panose="020B0604020202020204" pitchFamily="34" charset="0"/>
-              <a:buChar char="•"/>
-            </a:pPr>
-            <a:r>
-              <a:rPr lang="pt-PT" sz="4400" b="1" dirty="0"/>
-              <a:t>Análise de FPS </a:t>
-            </a:r>
-            <a:r>
-              <a:rPr lang="pt-PT" sz="4400" dirty="0"/>
-              <a:t>– Avaliação de desempenho</a:t>
-            </a:r>
-          </a:p>
-          <a:p>
-            <a:endParaRPr lang="pt-PT" dirty="0"/>
           </a:p>
         </p:txBody>
       </p:sp>

</xml_diff>